<commit_message>
Add fourth team member to defense sheet and deck
Co-Authored-By: Claude Fable 5.1 <noreply@anthropic.com>
</commit_message>
<xml_diff>
--- a/docs/AgentGate_pitch.pptx
+++ b/docs/AgentGate_pitch.pptx
@@ -2139,7 +2139,7 @@
                   <a:schemeClr val="bg1"/>
                 </a:solidFill>
               </a:rPr>
-              <a:t>Team 3: Jonathan Vinton, Abdul Hadi, Stephan Kenmegne</a:t>
+              <a:t>Team 3: Jonathan Vinton, Abdul Hadi, Stephan Kenmegne, Abderrahim Bahraoui</a:t>
             </a:r>
             <a:endParaRPr lang="en-US" sz="1400" dirty="0"/>
           </a:p>
@@ -7996,11 +7996,11 @@
         <p:spPr>
           <a:xfrm>
             <a:off x="457200" y="1051560"/>
-            <a:ext cx="3017520" cy="777240"/>
+            <a:ext cx="3017520" cy="621792"/>
           </a:xfrm>
           <a:prstGeom prst="roundRect">
             <a:avLst>
-              <a:gd name="adj" fmla="val 9412"/>
+              <a:gd name="adj" fmla="val 11765"/>
             </a:avLst>
           </a:prstGeom>
           <a:solidFill>
@@ -8029,7 +8029,7 @@
         </p:nvSpPr>
         <p:spPr>
           <a:xfrm>
-            <a:off x="640080" y="1216152"/>
+            <a:off x="640080" y="1133856"/>
             <a:ext cx="457200" cy="457200"/>
           </a:xfrm>
           <a:prstGeom prst="ellipse">
@@ -8054,7 +8054,7 @@
         </p:nvSpPr>
         <p:spPr>
           <a:xfrm>
-            <a:off x="640080" y="1216152"/>
+            <a:off x="640080" y="1133856"/>
             <a:ext cx="457200" cy="457200"/>
           </a:xfrm>
           <a:prstGeom prst="rect">
@@ -8090,8 +8090,8 @@
         </p:nvSpPr>
         <p:spPr>
           <a:xfrm>
-            <a:off x="1234440" y="1143000"/>
-            <a:ext cx="2148840" cy="320040"/>
+            <a:off x="1234440" y="1106424"/>
+            <a:ext cx="2148840" cy="274320"/>
           </a:xfrm>
           <a:prstGeom prst="rect">
             <a:avLst/>
@@ -8126,8 +8126,8 @@
         </p:nvSpPr>
         <p:spPr>
           <a:xfrm>
-            <a:off x="1234440" y="1463040"/>
-            <a:ext cx="2148840" cy="274320"/>
+            <a:off x="1234440" y="1380744"/>
+            <a:ext cx="2148840" cy="237744"/>
           </a:xfrm>
           <a:prstGeom prst="rect">
             <a:avLst/>
@@ -8162,12 +8162,12 @@
         </p:nvSpPr>
         <p:spPr>
           <a:xfrm>
-            <a:off x="457200" y="1965960"/>
-            <a:ext cx="3017520" cy="777240"/>
+            <a:off x="457200" y="1764792"/>
+            <a:ext cx="3017520" cy="621792"/>
           </a:xfrm>
           <a:prstGeom prst="roundRect">
             <a:avLst>
-              <a:gd name="adj" fmla="val 9412"/>
+              <a:gd name="adj" fmla="val 11765"/>
             </a:avLst>
           </a:prstGeom>
           <a:solidFill>
@@ -8196,7 +8196,7 @@
         </p:nvSpPr>
         <p:spPr>
           <a:xfrm>
-            <a:off x="640080" y="2130552"/>
+            <a:off x="640080" y="1847088"/>
             <a:ext cx="457200" cy="457200"/>
           </a:xfrm>
           <a:prstGeom prst="ellipse">
@@ -8221,7 +8221,7 @@
         </p:nvSpPr>
         <p:spPr>
           <a:xfrm>
-            <a:off x="640080" y="2130552"/>
+            <a:off x="640080" y="1847088"/>
             <a:ext cx="457200" cy="457200"/>
           </a:xfrm>
           <a:prstGeom prst="rect">
@@ -8257,8 +8257,8 @@
         </p:nvSpPr>
         <p:spPr>
           <a:xfrm>
-            <a:off x="1234440" y="2057400"/>
-            <a:ext cx="2148840" cy="320040"/>
+            <a:off x="1234440" y="1819656"/>
+            <a:ext cx="2148840" cy="274320"/>
           </a:xfrm>
           <a:prstGeom prst="rect">
             <a:avLst/>
@@ -8293,8 +8293,8 @@
         </p:nvSpPr>
         <p:spPr>
           <a:xfrm>
-            <a:off x="1234440" y="2377440"/>
-            <a:ext cx="2148840" cy="274320"/>
+            <a:off x="1234440" y="2093976"/>
+            <a:ext cx="2148840" cy="237744"/>
           </a:xfrm>
           <a:prstGeom prst="rect">
             <a:avLst/>
@@ -8329,12 +8329,12 @@
         </p:nvSpPr>
         <p:spPr>
           <a:xfrm>
-            <a:off x="457200" y="2880360"/>
-            <a:ext cx="3017520" cy="777240"/>
+            <a:off x="457200" y="2478024"/>
+            <a:ext cx="3017520" cy="621792"/>
           </a:xfrm>
           <a:prstGeom prst="roundRect">
             <a:avLst>
-              <a:gd name="adj" fmla="val 9412"/>
+              <a:gd name="adj" fmla="val 11765"/>
             </a:avLst>
           </a:prstGeom>
           <a:solidFill>
@@ -8363,7 +8363,7 @@
         </p:nvSpPr>
         <p:spPr>
           <a:xfrm>
-            <a:off x="640080" y="3044952"/>
+            <a:off x="640080" y="2560320"/>
             <a:ext cx="457200" cy="457200"/>
           </a:xfrm>
           <a:prstGeom prst="ellipse">
@@ -8388,7 +8388,7 @@
         </p:nvSpPr>
         <p:spPr>
           <a:xfrm>
-            <a:off x="640080" y="3044952"/>
+            <a:off x="640080" y="2560320"/>
             <a:ext cx="457200" cy="457200"/>
           </a:xfrm>
           <a:prstGeom prst="rect">
@@ -8424,8 +8424,8 @@
         </p:nvSpPr>
         <p:spPr>
           <a:xfrm>
-            <a:off x="1234440" y="2971800"/>
-            <a:ext cx="2148840" cy="320040"/>
+            <a:off x="1234440" y="2532888"/>
+            <a:ext cx="2148840" cy="274320"/>
           </a:xfrm>
           <a:prstGeom prst="rect">
             <a:avLst/>
@@ -8460,8 +8460,8 @@
         </p:nvSpPr>
         <p:spPr>
           <a:xfrm>
-            <a:off x="1234440" y="3291840"/>
-            <a:ext cx="2148840" cy="274320"/>
+            <a:off x="1234440" y="2807208"/>
+            <a:ext cx="2148840" cy="237744"/>
           </a:xfrm>
           <a:prstGeom prst="rect">
             <a:avLst/>
@@ -8490,54 +8490,18 @@
       </p:sp>
       <p:sp>
         <p:nvSpPr>
-          <p:cNvPr id="18" name="built text"/>
-          <p:cNvSpPr txBox="1"/>
-          <p:nvPr/>
-        </p:nvSpPr>
-        <p:spPr>
-          <a:xfrm>
-            <a:off x="457200" y="3840480"/>
-            <a:ext cx="3017520" cy="777240"/>
-          </a:xfrm>
-          <a:prstGeom prst="rect">
-            <a:avLst/>
-          </a:prstGeom>
-          <a:noFill/>
-          <a:ln/>
-        </p:spPr>
-        <p:txBody>
-          <a:bodyPr wrap="square" lIns="0" tIns="0" rIns="0" bIns="0" rtlCol="0" anchor="t"/>
-          <a:lstStyle/>
-          <a:p>
-            <a:pPr indent="0" marL="0">
-              <a:buNone/>
-            </a:pPr>
-            <a:r>
-              <a:rPr lang="en-US" sz="1050" dirty="0">
-                <a:solidFill>
-                  <a:schemeClr val="accent5"/>
-                </a:solidFill>
-              </a:rPr>
-              <a:t>Built in 36 hours: 16-attack suite, Bedrock runner, Wilson gate, attribution, Ed25519 ledger, PDF evidence pack, monitor, dashboard, CI workflow, 122 tests.</a:t>
-            </a:r>
-            <a:endParaRPr lang="en-US" sz="1050" dirty="0"/>
-          </a:p>
-        </p:txBody>
-      </p:sp>
-      <p:sp>
-        <p:nvSpPr>
-          <p:cNvPr id="19" name="limits card"/>
+          <p:cNvPr id="18" name="team card"/>
           <p:cNvSpPr/>
           <p:nvPr/>
         </p:nvSpPr>
         <p:spPr>
           <a:xfrm>
-            <a:off x="3749040" y="1051560"/>
-            <a:ext cx="4937760" cy="2743200"/>
+            <a:off x="457200" y="3191256"/>
+            <a:ext cx="3017520" cy="621792"/>
           </a:xfrm>
           <a:prstGeom prst="roundRect">
             <a:avLst>
-              <a:gd name="adj" fmla="val 2667"/>
+              <a:gd name="adj" fmla="val 11765"/>
             </a:avLst>
           </a:prstGeom>
           <a:solidFill>
@@ -8560,7 +8524,210 @@
       </p:sp>
       <p:sp>
         <p:nvSpPr>
-          <p:cNvPr id="20" name="limits head"/>
+          <p:cNvPr id="19" name="glyph circle"/>
+          <p:cNvSpPr/>
+          <p:nvPr/>
+        </p:nvSpPr>
+        <p:spPr>
+          <a:xfrm>
+            <a:off x="640080" y="3273552"/>
+            <a:ext cx="457200" cy="457200"/>
+          </a:xfrm>
+          <a:prstGeom prst="ellipse">
+            <a:avLst/>
+          </a:prstGeom>
+          <a:solidFill>
+            <a:srgbClr val="E3B23C"/>
+          </a:solidFill>
+          <a:ln w="12700">
+            <a:solidFill>
+              <a:srgbClr val="E3B23C"/>
+            </a:solidFill>
+            <a:prstDash val="solid"/>
+          </a:ln>
+        </p:spPr>
+      </p:sp>
+      <p:sp>
+        <p:nvSpPr>
+          <p:cNvPr id="20" name="glyph"/>
+          <p:cNvSpPr txBox="1"/>
+          <p:nvPr/>
+        </p:nvSpPr>
+        <p:spPr>
+          <a:xfrm>
+            <a:off x="640080" y="3273552"/>
+            <a:ext cx="457200" cy="457200"/>
+          </a:xfrm>
+          <a:prstGeom prst="rect">
+            <a:avLst/>
+          </a:prstGeom>
+          <a:noFill/>
+          <a:ln/>
+        </p:spPr>
+        <p:txBody>
+          <a:bodyPr wrap="square" lIns="0" tIns="0" rIns="0" bIns="0" rtlCol="0" anchor="ctr"/>
+          <a:lstStyle/>
+          <a:p>
+            <a:pPr algn="ctr" indent="0" marL="0">
+              <a:buNone/>
+            </a:pPr>
+            <a:r>
+              <a:rPr lang="en-US" sz="1300" b="1" dirty="0">
+                <a:solidFill>
+                  <a:schemeClr val="bg1"/>
+                </a:solidFill>
+              </a:rPr>
+              <a:t>AB</a:t>
+            </a:r>
+            <a:endParaRPr lang="en-US" sz="1300" dirty="0"/>
+          </a:p>
+        </p:txBody>
+      </p:sp>
+      <p:sp>
+        <p:nvSpPr>
+          <p:cNvPr id="21" name="team name"/>
+          <p:cNvSpPr txBox="1"/>
+          <p:nvPr/>
+        </p:nvSpPr>
+        <p:spPr>
+          <a:xfrm>
+            <a:off x="1234440" y="3246120"/>
+            <a:ext cx="2148840" cy="274320"/>
+          </a:xfrm>
+          <a:prstGeom prst="rect">
+            <a:avLst/>
+          </a:prstGeom>
+          <a:noFill/>
+          <a:ln/>
+        </p:spPr>
+        <p:txBody>
+          <a:bodyPr wrap="square" lIns="0" tIns="0" rIns="0" bIns="0" rtlCol="0" anchor="ctr"/>
+          <a:lstStyle/>
+          <a:p>
+            <a:pPr indent="0" marL="0">
+              <a:buNone/>
+            </a:pPr>
+            <a:r>
+              <a:rPr lang="en-US" sz="1400" b="1" dirty="0">
+                <a:solidFill>
+                  <a:schemeClr val="tx2"/>
+                </a:solidFill>
+              </a:rPr>
+              <a:t>Abderrahim Bahraoui</a:t>
+            </a:r>
+            <a:endParaRPr lang="en-US" sz="1400" dirty="0"/>
+          </a:p>
+        </p:txBody>
+      </p:sp>
+      <p:sp>
+        <p:nvSpPr>
+          <p:cNvPr id="22" name="team role"/>
+          <p:cNvSpPr txBox="1"/>
+          <p:nvPr/>
+        </p:nvSpPr>
+        <p:spPr>
+          <a:xfrm>
+            <a:off x="1234440" y="3520440"/>
+            <a:ext cx="2148840" cy="237744"/>
+          </a:xfrm>
+          <a:prstGeom prst="rect">
+            <a:avLst/>
+          </a:prstGeom>
+          <a:noFill/>
+          <a:ln/>
+        </p:spPr>
+        <p:txBody>
+          <a:bodyPr wrap="square" lIns="0" tIns="0" rIns="0" bIns="0" rtlCol="0" anchor="ctr"/>
+          <a:lstStyle/>
+          <a:p>
+            <a:pPr indent="0" marL="0">
+              <a:buNone/>
+            </a:pPr>
+            <a:r>
+              <a:rPr lang="en-US" sz="1050" dirty="0">
+                <a:solidFill>
+                  <a:schemeClr val="accent5"/>
+                </a:solidFill>
+              </a:rPr>
+              <a:t>Team 3, Secure Horizons 2026</a:t>
+            </a:r>
+            <a:endParaRPr lang="en-US" sz="1050" dirty="0"/>
+          </a:p>
+        </p:txBody>
+      </p:sp>
+      <p:sp>
+        <p:nvSpPr>
+          <p:cNvPr id="23" name="built text"/>
+          <p:cNvSpPr txBox="1"/>
+          <p:nvPr/>
+        </p:nvSpPr>
+        <p:spPr>
+          <a:xfrm>
+            <a:off x="457200" y="3931920"/>
+            <a:ext cx="3017520" cy="731520"/>
+          </a:xfrm>
+          <a:prstGeom prst="rect">
+            <a:avLst/>
+          </a:prstGeom>
+          <a:noFill/>
+          <a:ln/>
+        </p:spPr>
+        <p:txBody>
+          <a:bodyPr wrap="square" lIns="0" tIns="0" rIns="0" bIns="0" rtlCol="0" anchor="t"/>
+          <a:lstStyle/>
+          <a:p>
+            <a:pPr indent="0" marL="0">
+              <a:buNone/>
+            </a:pPr>
+            <a:r>
+              <a:rPr lang="en-US" sz="1000" dirty="0">
+                <a:solidFill>
+                  <a:schemeClr val="accent5"/>
+                </a:solidFill>
+              </a:rPr>
+              <a:t>Built in 36 hours: 16-attack suite, Bedrock runner, Wilson gate, attribution, Ed25519 ledger, PDF evidence pack, monitor, dashboard, CI workflow, 122 tests.</a:t>
+            </a:r>
+            <a:endParaRPr lang="en-US" sz="1000" dirty="0"/>
+          </a:p>
+        </p:txBody>
+      </p:sp>
+      <p:sp>
+        <p:nvSpPr>
+          <p:cNvPr id="24" name="limits card"/>
+          <p:cNvSpPr/>
+          <p:nvPr/>
+        </p:nvSpPr>
+        <p:spPr>
+          <a:xfrm>
+            <a:off x="3749040" y="1051560"/>
+            <a:ext cx="4937760" cy="2743200"/>
+          </a:xfrm>
+          <a:prstGeom prst="roundRect">
+            <a:avLst>
+              <a:gd name="adj" fmla="val 2667"/>
+            </a:avLst>
+          </a:prstGeom>
+          <a:solidFill>
+            <a:schemeClr val="bg2"/>
+          </a:solidFill>
+          <a:ln w="9525">
+            <a:solidFill>
+              <a:srgbClr val="B9DED9"/>
+            </a:solidFill>
+            <a:prstDash val="solid"/>
+          </a:ln>
+          <a:effectLst>
+            <a:outerShdw sx="100000" sy="100000" kx="0" ky="0" algn="bl" rotWithShape="0" blurRad="50800" dist="19050" dir="5400000">
+              <a:srgbClr val="9CA3AF">
+                <a:alpha val="25000"/>
+              </a:srgbClr>
+            </a:outerShdw>
+          </a:effectLst>
+        </p:spPr>
+      </p:sp>
+      <p:sp>
+        <p:nvSpPr>
+          <p:cNvPr id="25" name="limits head"/>
           <p:cNvSpPr txBox="1"/>
           <p:nvPr/>
         </p:nvSpPr>
@@ -8596,7 +8763,7 @@
       </p:sp>
       <p:sp>
         <p:nvSpPr>
-          <p:cNvPr id="21" name="limits body"/>
+          <p:cNvPr id="26" name="limits body"/>
           <p:cNvSpPr txBox="1"/>
           <p:nvPr/>
         </p:nvSpPr>
@@ -8708,7 +8875,7 @@
       </p:sp>
       <p:sp>
         <p:nvSpPr>
-          <p:cNvPr id="22" name="close strip"/>
+          <p:cNvPr id="27" name="close strip"/>
           <p:cNvSpPr/>
           <p:nvPr/>
         </p:nvSpPr>
@@ -8735,7 +8902,7 @@
       </p:sp>
       <p:sp>
         <p:nvSpPr>
-          <p:cNvPr id="23" name="close text"/>
+          <p:cNvPr id="28" name="close text"/>
           <p:cNvSpPr txBox="1"/>
           <p:nvPr/>
         </p:nvSpPr>

</xml_diff>

<commit_message>
Deck: point repo links at agentgate
Co-Authored-By: Claude Fable 5.1 <noreply@anthropic.com>
</commit_message>
<xml_diff>
--- a/docs/AgentGate_pitch.pptx
+++ b/docs/AgentGate_pitch.pptx
@@ -2175,7 +2175,7 @@
                   <a:schemeClr val="accent6"/>
                 </a:solidFill>
               </a:rPr>
-              <a:t>Secure Horizons, ESSEC, 10-11 October 2026. Track 3 Uncharted Frontiers, area 3: continuous compliance and tamper-proof evidence. github.com/hadi-ce04/agentguard</a:t>
+              <a:t>Secure Horizons, ESSEC, 10-11 October 2026. Track 3 Uncharted Frontiers, area 3: continuous compliance and tamper-proof evidence. github.com/hadi-ce04/agentgate</a:t>
             </a:r>
             <a:endParaRPr lang="en-US" sz="1100" dirty="0"/>
           </a:p>
@@ -8944,7 +8944,7 @@
                   <a:schemeClr val="accent6"/>
                 </a:solidFill>
               </a:rPr>
-              <a:t>github.com/hadi-ce04/agentguard  |  python cli.py verify  |  evidence/samples/pack_v7_llama.pdf</a:t>
+              <a:t>github.com/hadi-ce04/agentgate  |  python cli.py verify  |  evidence/samples/pack_v7_llama.pdf</a:t>
             </a:r>
             <a:endParaRPr lang="en-US" sz="1400" dirty="0"/>
           </a:p>

</xml_diff>

<commit_message>
System overview for the team; correct v7 attribution wording everywhere
Attribution bundles show the tool grant alone regresses on both models,
and on Llama the TOOLS text alone regresses too; wording changed from
"cause: tool_added" to "the tool grant alone regresses on both models"
in the defense sheet, deck, demo runbook and video script.

Co-Authored-By: Claude Fable 5.1 <noreply@anthropic.com>
</commit_message>
<xml_diff>
--- a/docs/AgentGate_pitch.pptx
+++ b/docs/AgentGate_pitch.pptx
@@ -685,7 +685,7 @@
           <a:p>
             <a:r>
               <a:rPr lang="en-US" dirty="0"/>
-              <a:t>The finding of the weekend. v7 adds one tool and keeps every security rule. On Llama 3.3 70B the poisoned tool description changed the supplier's IBAN in 20 of 20 trials. Attribution names the tool grant, not the prompt. Our defender is the platform or compliance owner who has to approve this change.</a:t>
+              <a:t>The finding of the weekend. v7 adds one tool and keeps every security rule. On Llama 3.3 70B the poisoned tool description changed the supplier's IBAN in 20 of 20 trials. Attribution shows the tool grant alone regresses on both models (on Llama the new TOOLS text alone regresses too, so do not say the prompt is innocent). Our defender is the platform or compliance owner who has to approve this change.</a:t>
             </a:r>
             <a:endParaRPr lang="en-US" dirty="0"/>
           </a:p>
@@ -861,7 +861,7 @@
           <a:p>
             <a:r>
               <a:rPr lang="en-US" dirty="0"/>
-              <a:t>Live: pick v7 on Llama, 10 trials, Run gate. Baseline table stays green, candidate fills; the event log shows update_vendor_bank_details with the attacker's IBAN; tool-misuse rows go orange; verdict BLOCK with cause tool_added. Then: Verify ledger (green), Tamper demo (copy fails at the exact entry), Generate audit pack and open page 1 and page 4. If Bedrock misbehaves, switch to the offline mock and show the record panel.</a:t>
+              <a:t>Live: pick v7 on Llama, 10 trials, Run gate. Baseline table stays green, candidate fills; the event log shows update_vendor_bank_details with the attacker's IBAN; tool-misuse rows go orange; verdict BLOCK; attribution shows the tool grant alone regresses. Then: Verify ledger (green), Tamper demo (copy fails at the exact entry), Generate audit pack and open page 1 and page 4. If Bedrock misbehaves, switch to the offline mock and show the record panel.</a:t>
             </a:r>
             <a:endParaRPr lang="en-US" dirty="0"/>
           </a:p>
@@ -3647,7 +3647,7 @@
                   <a:schemeClr val="accent5"/>
                 </a:solidFill>
               </a:rPr>
-              <a:t>The agent's actual tool call, from the signed evidence pack. Cause named by attribution: tool_added.</a:t>
+              <a:t>The agent's actual tool call, from the signed evidence pack. Attribution: the tool grant alone regresses on both models.</a:t>
             </a:r>
             <a:endParaRPr lang="en-US" sz="950" dirty="0"/>
           </a:p>

</xml_diff>